<commit_message>
Fix screenshot grid overflow on the Live Product slide, add PDF export
The 2x2 screenshot grid on slide 4 had a layout bug pushing the second
row past the slide bottom edge. Recomputes row spacing to fit within
bounds (verified programmatically: zero overflowing shapes) and crops
the tall full-page screenshots to a cleaner top slice for the grid.
Also exports ForgeMind-AI-Pitch-Deck.pdf for easier sharing/viewing.

Co-Authored-By: Claude Sonnet 5 <noreply@anthropic.com>
</commit_message>
<xml_diff>
--- a/ForgeMind-AI-Pitch-Deck.pptx
+++ b/ForgeMind-AI-Pitch-Deck.pptx
@@ -5121,8 +5121,8 @@
         </p:nvSpPr>
         <p:spPr>
           <a:xfrm>
-            <a:off x="1517288" y="1483760"/>
-            <a:ext cx="3366224" cy="2381720"/>
+            <a:off x="1744872" y="1392320"/>
+            <a:ext cx="2911056" cy="2061679"/>
           </a:xfrm>
           <a:prstGeom prst="rect">
             <a:avLst/>
@@ -5159,7 +5159,7 @@
       </p:sp>
       <p:pic>
         <p:nvPicPr>
-          <p:cNvPr id="8" name="Picture 7" descr="02-upload.png"/>
+          <p:cNvPr id="8" name="Picture 7" descr="crop-02-upload.png"/>
           <p:cNvPicPr>
             <a:picLocks noChangeAspect="1"/>
           </p:cNvPicPr>
@@ -5173,8 +5173,8 @@
         </p:blipFill>
         <p:spPr>
           <a:xfrm>
-            <a:off x="1542288" y="1508760"/>
-            <a:ext cx="3316224" cy="2331720"/>
+            <a:off x="1769872" y="1417320"/>
+            <a:ext cx="2861056" cy="2011679"/>
           </a:xfrm>
           <a:prstGeom prst="rect">
             <a:avLst/>
@@ -5189,8 +5189,8 @@
         </p:nvSpPr>
         <p:spPr>
           <a:xfrm>
-            <a:off x="502920" y="3886200"/>
-            <a:ext cx="5394960" cy="274320"/>
+            <a:off x="502920" y="3456432"/>
+            <a:ext cx="5394960" cy="256032"/>
           </a:xfrm>
           <a:prstGeom prst="rect">
             <a:avLst/>
@@ -5227,8 +5227,8 @@
         </p:nvSpPr>
         <p:spPr>
           <a:xfrm>
-            <a:off x="8437281" y="1483760"/>
-            <a:ext cx="864797" cy="2381720"/>
+            <a:off x="7235336" y="1392320"/>
+            <a:ext cx="3268688" cy="2061680"/>
           </a:xfrm>
           <a:prstGeom prst="rect">
             <a:avLst/>
@@ -5265,7 +5265,7 @@
       </p:sp>
       <p:pic>
         <p:nvPicPr>
-          <p:cNvPr id="11" name="Picture 10" descr="03-knowledge-search.png"/>
+          <p:cNvPr id="11" name="Picture 10" descr="crop-03-knowledge-search.png"/>
           <p:cNvPicPr>
             <a:picLocks noChangeAspect="1"/>
           </p:cNvPicPr>
@@ -5279,8 +5279,8 @@
         </p:blipFill>
         <p:spPr>
           <a:xfrm>
-            <a:off x="8462281" y="1508760"/>
-            <a:ext cx="814797" cy="2331720"/>
+            <a:off x="7260336" y="1417320"/>
+            <a:ext cx="3218688" cy="2011680"/>
           </a:xfrm>
           <a:prstGeom prst="rect">
             <a:avLst/>
@@ -5295,8 +5295,8 @@
         </p:nvSpPr>
         <p:spPr>
           <a:xfrm>
-            <a:off x="6172200" y="3886200"/>
-            <a:ext cx="5394960" cy="274320"/>
+            <a:off x="6172200" y="3456432"/>
+            <a:ext cx="5394960" cy="256032"/>
           </a:xfrm>
           <a:prstGeom prst="rect">
             <a:avLst/>
@@ -5333,8 +5333,8 @@
         </p:nvSpPr>
         <p:spPr>
           <a:xfrm>
-            <a:off x="2402187" y="4409840"/>
-            <a:ext cx="1596425" cy="2381720"/>
+            <a:off x="1660723" y="3797192"/>
+            <a:ext cx="3079353" cy="2061679"/>
           </a:xfrm>
           <a:prstGeom prst="rect">
             <a:avLst/>
@@ -5371,7 +5371,7 @@
       </p:sp>
       <p:pic>
         <p:nvPicPr>
-          <p:cNvPr id="14" name="Picture 13" descr="06-ask-ai-answer.png"/>
+          <p:cNvPr id="14" name="Picture 13" descr="crop-06-ask-ai-answer.png"/>
           <p:cNvPicPr>
             <a:picLocks noChangeAspect="1"/>
           </p:cNvPicPr>
@@ -5385,8 +5385,8 @@
         </p:blipFill>
         <p:spPr>
           <a:xfrm>
-            <a:off x="2427187" y="4434840"/>
-            <a:ext cx="1546425" cy="2331720"/>
+            <a:off x="1685723" y="3822192"/>
+            <a:ext cx="3029353" cy="2011679"/>
           </a:xfrm>
           <a:prstGeom prst="rect">
             <a:avLst/>
@@ -5401,8 +5401,8 @@
         </p:nvSpPr>
         <p:spPr>
           <a:xfrm>
-            <a:off x="502920" y="6812280"/>
-            <a:ext cx="5394960" cy="274320"/>
+            <a:off x="502920" y="5861304"/>
+            <a:ext cx="5394960" cy="256032"/>
           </a:xfrm>
           <a:prstGeom prst="rect">
             <a:avLst/>
@@ -5439,8 +5439,8 @@
         </p:nvSpPr>
         <p:spPr>
           <a:xfrm>
-            <a:off x="7911992" y="4409840"/>
-            <a:ext cx="1915376" cy="2381720"/>
+            <a:off x="7330003" y="3797192"/>
+            <a:ext cx="3079353" cy="2061679"/>
           </a:xfrm>
           <a:prstGeom prst="rect">
             <a:avLst/>
@@ -5477,7 +5477,7 @@
       </p:sp>
       <p:pic>
         <p:nvPicPr>
-          <p:cNvPr id="17" name="Picture 16" descr="09-insights.png"/>
+          <p:cNvPr id="17" name="Picture 16" descr="crop-09-insights.png"/>
           <p:cNvPicPr>
             <a:picLocks noChangeAspect="1"/>
           </p:cNvPicPr>
@@ -5491,8 +5491,8 @@
         </p:blipFill>
         <p:spPr>
           <a:xfrm>
-            <a:off x="7936992" y="4434840"/>
-            <a:ext cx="1865376" cy="2331720"/>
+            <a:off x="7355003" y="3822192"/>
+            <a:ext cx="3029353" cy="2011679"/>
           </a:xfrm>
           <a:prstGeom prst="rect">
             <a:avLst/>
@@ -5507,8 +5507,8 @@
         </p:nvSpPr>
         <p:spPr>
           <a:xfrm>
-            <a:off x="6172200" y="6812280"/>
-            <a:ext cx="5394960" cy="274320"/>
+            <a:off x="6172200" y="5861304"/>
+            <a:ext cx="5394960" cy="256032"/>
           </a:xfrm>
           <a:prstGeom prst="rect">
             <a:avLst/>

</xml_diff>